<commit_message>
Containerise pipeline; read config from environment
</commit_message>
<xml_diff>
--- a/assets/template.pptx
+++ b/assets/template.pptx
@@ -2293,7 +2293,7 @@
           <a:p>
             <a:r>
               <a:rPr/>
-              <a:t>22 June 2026</a:t>
+              <a:t>08 September 2026</a:t>
             </a:r>
           </a:p>
         </p:txBody>
@@ -2428,7 +2428,7 @@
           <a:p>
             <a:r>
               <a:rPr/>
-              <a:t>22 June 2026</a:t>
+              <a:t>08 September 2026</a:t>
             </a:r>
           </a:p>
         </p:txBody>
@@ -2588,7 +2588,7 @@
           <a:p>
             <a:r>
               <a:rPr/>
-              <a:t>22 June 2026</a:t>
+              <a:t>08 September 2026</a:t>
             </a:r>
           </a:p>
         </p:txBody>
@@ -2721,7 +2721,7 @@
           <a:p>
             <a:r>
               <a:rPr/>
-              <a:t>22 June 2026</a:t>
+              <a:t>08 September 2026</a:t>
             </a:r>
           </a:p>
         </p:txBody>

</xml_diff>